<commit_message>
Rebuild documentation visuals with Vixl 0.20.0
Regenerate docs/assets/generated, the example poster and its master with
0.20.0 (builders now pass overwrite=True). Add reproducible builders for
the filter, organic and irregular galleries and the drawing pipeline,
which were previously made by uncommitted one-off code.

Co-Authored-By: Claude Opus 5.5 <noreply@anthropic.com>
Claude-Session: https://claude.ai/code/session_014NqAoPUDZ9CN18Yp3vYbtS
</commit_message>
<xml_diff>
--- a/docs/assets/generated/slides.pptx
+++ b/docs/assets/generated/slides.pptx
@@ -405,8 +405,8 @@
         </p:nvSpPr>
         <p:spPr>
           <a:xfrm>
-            <a:off x="510264" y="248947"/>
-            <a:ext cx="8932689" cy="546351"/>
+            <a:off x="553250" y="248947"/>
+            <a:ext cx="8990319" cy="546351"/>
           </a:xfrm>
           <a:prstGeom prst="rect">
             <a:avLst/>
@@ -448,7 +448,7 @@
         </p:nvSpPr>
         <p:spPr>
           <a:xfrm>
-            <a:off x="551449" y="929355"/>
+            <a:off x="553250" y="929355"/>
             <a:ext cx="3962080" cy="292406"/>
           </a:xfrm>
           <a:prstGeom prst="rect">
@@ -558,7 +558,7 @@
         </p:nvSpPr>
         <p:spPr>
           <a:xfrm>
-            <a:off x="919923" y="3653263"/>
+            <a:off x="922084" y="3653263"/>
             <a:ext cx="9206433" cy="369329"/>
           </a:xfrm>
           <a:prstGeom prst="rect">
@@ -638,8 +638,8 @@
         </p:nvSpPr>
         <p:spPr>
           <a:xfrm>
-            <a:off x="510264" y="248947"/>
-            <a:ext cx="5157908" cy="546351"/>
+            <a:off x="553250" y="248947"/>
+            <a:ext cx="5215538" cy="546351"/>
           </a:xfrm>
           <a:prstGeom prst="rect">
             <a:avLst/>
@@ -681,8 +681,8 @@
         </p:nvSpPr>
         <p:spPr>
           <a:xfrm>
-            <a:off x="530626" y="929355"/>
-            <a:ext cx="6036769" cy="315458"/>
+            <a:off x="553250" y="929355"/>
+            <a:ext cx="6065584" cy="315458"/>
           </a:xfrm>
           <a:prstGeom prst="rect">
             <a:avLst/>
@@ -724,8 +724,8 @@
         </p:nvSpPr>
         <p:spPr>
           <a:xfrm>
-            <a:off x="526101" y="1889777"/>
-            <a:ext cx="1094975" cy="311699"/>
+            <a:off x="553250" y="1889777"/>
+            <a:ext cx="1118027" cy="311699"/>
           </a:xfrm>
           <a:prstGeom prst="rect">
             <a:avLst/>
@@ -791,8 +791,8 @@
         </p:nvSpPr>
         <p:spPr>
           <a:xfrm>
-            <a:off x="11021696" y="1838810"/>
-            <a:ext cx="749193" cy="305035"/>
+            <a:off x="11041956" y="1838810"/>
+            <a:ext cx="772245" cy="305035"/>
           </a:xfrm>
           <a:prstGeom prst="rect">
             <a:avLst/>
@@ -834,8 +834,8 @@
         </p:nvSpPr>
         <p:spPr>
           <a:xfrm>
-            <a:off x="526101" y="2904069"/>
-            <a:ext cx="1383126" cy="311699"/>
+            <a:off x="553250" y="2904069"/>
+            <a:ext cx="1406178" cy="311699"/>
           </a:xfrm>
           <a:prstGeom prst="rect">
             <a:avLst/>
@@ -901,8 +901,8 @@
         </p:nvSpPr>
         <p:spPr>
           <a:xfrm>
-            <a:off x="11020885" y="2853103"/>
-            <a:ext cx="749193" cy="316561"/>
+            <a:off x="11041956" y="2853103"/>
+            <a:ext cx="772245" cy="316561"/>
           </a:xfrm>
           <a:prstGeom prst="rect">
             <a:avLst/>
@@ -944,8 +944,8 @@
         </p:nvSpPr>
         <p:spPr>
           <a:xfrm>
-            <a:off x="526101" y="3918362"/>
-            <a:ext cx="1267866" cy="311699"/>
+            <a:off x="553250" y="3918362"/>
+            <a:ext cx="1290918" cy="311699"/>
           </a:xfrm>
           <a:prstGeom prst="rect">
             <a:avLst/>
@@ -1011,8 +1011,8 @@
         </p:nvSpPr>
         <p:spPr>
           <a:xfrm>
-            <a:off x="11020615" y="3867395"/>
-            <a:ext cx="749193" cy="316561"/>
+            <a:off x="11041956" y="3867395"/>
+            <a:ext cx="772245" cy="316561"/>
           </a:xfrm>
           <a:prstGeom prst="rect">
             <a:avLst/>
@@ -1054,8 +1054,8 @@
         </p:nvSpPr>
         <p:spPr>
           <a:xfrm>
-            <a:off x="526101" y="4932654"/>
-            <a:ext cx="1383126" cy="311699"/>
+            <a:off x="553250" y="4932654"/>
+            <a:ext cx="1406178" cy="311699"/>
           </a:xfrm>
           <a:prstGeom prst="rect">
             <a:avLst/>
@@ -1121,8 +1121,8 @@
         </p:nvSpPr>
         <p:spPr>
           <a:xfrm>
-            <a:off x="11022641" y="4881688"/>
-            <a:ext cx="749193" cy="316561"/>
+            <a:off x="11041956" y="4881688"/>
+            <a:ext cx="772245" cy="316561"/>
           </a:xfrm>
           <a:prstGeom prst="rect">
             <a:avLst/>

</xml_diff>

<commit_message>
Rebuild documentation and brand assets with the current engine
Regenerate docs/assets/generated, the docs galleries, the README poster and its
editable master, the template and texture images, the cut-paper preview, the
emoji review sheets and the Ripple kit, then refresh the packaged browser SVGs
and Windows ICO. build_documentation.py saves masters with overwrite=True so it
can run over the committed outputs.
</commit_message>
<xml_diff>
--- a/docs/assets/generated/slides.pptx
+++ b/docs/assets/generated/slides.pptx
@@ -405,8 +405,8 @@
         </p:nvSpPr>
         <p:spPr>
           <a:xfrm>
-            <a:off x="553250" y="248947"/>
-            <a:ext cx="8990319" cy="546351"/>
+            <a:off x="553250" y="318103"/>
+            <a:ext cx="8990319" cy="477194"/>
           </a:xfrm>
           <a:prstGeom prst="rect">
             <a:avLst/>
@@ -421,7 +421,7 @@
           <a:p>
             <a:pPr algn="l">
               <a:lnSpc>
-                <a:spcPts val="4378"/>
+                <a:spcPts val="3833"/>
               </a:lnSpc>
               <a:buNone/>
             </a:pPr>
@@ -515,8 +515,8 @@
         </p:nvSpPr>
         <p:spPr>
           <a:xfrm>
-            <a:off x="923907" y="2327148"/>
-            <a:ext cx="7520748" cy="761834"/>
+            <a:off x="923907" y="2476987"/>
+            <a:ext cx="7520748" cy="611995"/>
           </a:xfrm>
           <a:prstGeom prst="rect">
             <a:avLst/>
@@ -531,7 +531,7 @@
           <a:p>
             <a:pPr algn="l">
               <a:lnSpc>
-                <a:spcPts val="6068"/>
+                <a:spcPts val="4888"/>
               </a:lnSpc>
               <a:buNone/>
             </a:pPr>
@@ -638,8 +638,8 @@
         </p:nvSpPr>
         <p:spPr>
           <a:xfrm>
-            <a:off x="553250" y="248947"/>
-            <a:ext cx="5215538" cy="546351"/>
+            <a:off x="553250" y="318103"/>
+            <a:ext cx="5215538" cy="477194"/>
           </a:xfrm>
           <a:prstGeom prst="rect">
             <a:avLst/>
@@ -654,7 +654,7 @@
           <a:p>
             <a:pPr algn="l">
               <a:lnSpc>
-                <a:spcPts val="4378"/>
+                <a:spcPts val="3833"/>
               </a:lnSpc>
               <a:buNone/>
             </a:pPr>

</xml_diff>